<commit_message>
Actualiza informe y presentacion con correcciones finales
</commit_message>
<xml_diff>
--- a/docs/evidencias/Presentación Final - Proyecto 01.pptx
+++ b/docs/evidencias/Presentación Final - Proyecto 01.pptx
@@ -132,9 +132,305 @@
 <file path=ppt/revisionInfo.xml><?xml version="1.0" encoding="utf-8"?>
 <p1510:revInfo xmlns:a="http://schemas.openxmlformats.org/drawingml/2006/main" xmlns:r="http://schemas.openxmlformats.org/officeDocument/2006/relationships" xmlns:p1510="http://schemas.microsoft.com/office/powerpoint/2015/10/main">
   <p1510:revLst>
-    <p1510:client id="{0B110735-EF7C-724B-B683-068339DB2F9E}" v="1" dt="2026-10-01T02:52:06.458"/>
+    <p1510:client id="{0B110735-EF7C-724B-B683-068339DB2F9E}" v="29" dt="2026-10-28T02:43:02.025"/>
   </p1510:revLst>
 </p1510:revInfo>
+</file>
+
+<file path=ppt/changesInfos/changesInfo1.xml><?xml version="1.0" encoding="utf-8"?>
+<pc:chgInfo xmlns:a="http://schemas.openxmlformats.org/drawingml/2006/main" xmlns:r="http://schemas.openxmlformats.org/officeDocument/2006/relationships" xmlns:ac="http://schemas.microsoft.com/office/drawing/2013/main/command" xmlns:pc="http://schemas.microsoft.com/office/powerpoint/2013/main/command">
+  <pc:docChgLst>
+    <pc:chgData name="HARRIETT GUZMAN LOPEZ" userId="809bac81-b980-4645-9732-895bcfc5ae10" providerId="ADAL" clId="{5140C7B6-806A-5418-ABAC-628B6C6783E8}"/>
+    <pc:docChg chg="undo custSel modSld">
+      <pc:chgData name="HARRIETT GUZMAN LOPEZ" userId="809bac81-b980-4645-9732-895bcfc5ae10" providerId="ADAL" clId="{5140C7B6-806A-5418-ABAC-628B6C6783E8}" dt="2026-10-28T02:43:04.135" v="271" actId="20577"/>
+      <pc:docMkLst>
+        <pc:docMk/>
+      </pc:docMkLst>
+      <pc:sldChg chg="modSp mod">
+        <pc:chgData name="HARRIETT GUZMAN LOPEZ" userId="809bac81-b980-4645-9732-895bcfc5ae10" providerId="ADAL" clId="{5140C7B6-806A-5418-ABAC-628B6C6783E8}" dt="2026-10-28T02:33:46.277" v="11" actId="20577"/>
+        <pc:sldMkLst>
+          <pc:docMk/>
+          <pc:sldMk cId="0" sldId="260"/>
+        </pc:sldMkLst>
+        <pc:spChg chg="mod">
+          <ac:chgData name="HARRIETT GUZMAN LOPEZ" userId="809bac81-b980-4645-9732-895bcfc5ae10" providerId="ADAL" clId="{5140C7B6-806A-5418-ABAC-628B6C6783E8}" dt="2026-10-28T02:33:33.924" v="6" actId="20577"/>
+          <ac:spMkLst>
+            <pc:docMk/>
+            <pc:sldMk cId="0" sldId="260"/>
+            <ac:spMk id="4" creationId="{00000000-0000-0000-0000-000000000000}"/>
+          </ac:spMkLst>
+        </pc:spChg>
+        <pc:spChg chg="mod">
+          <ac:chgData name="HARRIETT GUZMAN LOPEZ" userId="809bac81-b980-4645-9732-895bcfc5ae10" providerId="ADAL" clId="{5140C7B6-806A-5418-ABAC-628B6C6783E8}" dt="2026-10-28T02:33:46.277" v="11" actId="20577"/>
+          <ac:spMkLst>
+            <pc:docMk/>
+            <pc:sldMk cId="0" sldId="260"/>
+            <ac:spMk id="10" creationId="{00000000-0000-0000-0000-000000000000}"/>
+          </ac:spMkLst>
+        </pc:spChg>
+      </pc:sldChg>
+      <pc:sldChg chg="addSp delSp modSp mod">
+        <pc:chgData name="HARRIETT GUZMAN LOPEZ" userId="809bac81-b980-4645-9732-895bcfc5ae10" providerId="ADAL" clId="{5140C7B6-806A-5418-ABAC-628B6C6783E8}" dt="2026-10-28T02:34:59.326" v="35" actId="478"/>
+        <pc:sldMkLst>
+          <pc:docMk/>
+          <pc:sldMk cId="0" sldId="263"/>
+        </pc:sldMkLst>
+        <pc:spChg chg="mod">
+          <ac:chgData name="HARRIETT GUZMAN LOPEZ" userId="809bac81-b980-4645-9732-895bcfc5ae10" providerId="ADAL" clId="{5140C7B6-806A-5418-ABAC-628B6C6783E8}" dt="2026-10-28T02:34:46.872" v="33" actId="20577"/>
+          <ac:spMkLst>
+            <pc:docMk/>
+            <pc:sldMk cId="0" sldId="263"/>
+            <ac:spMk id="14" creationId="{00000000-0000-0000-0000-000000000000}"/>
+          </ac:spMkLst>
+        </pc:spChg>
+        <pc:spChg chg="del mod">
+          <ac:chgData name="HARRIETT GUZMAN LOPEZ" userId="809bac81-b980-4645-9732-895bcfc5ae10" providerId="ADAL" clId="{5140C7B6-806A-5418-ABAC-628B6C6783E8}" dt="2026-10-28T02:34:59.326" v="35" actId="478"/>
+          <ac:spMkLst>
+            <pc:docMk/>
+            <pc:sldMk cId="0" sldId="263"/>
+            <ac:spMk id="15" creationId="{00000000-0000-0000-0000-000000000000}"/>
+          </ac:spMkLst>
+        </pc:spChg>
+        <pc:spChg chg="add">
+          <ac:chgData name="HARRIETT GUZMAN LOPEZ" userId="809bac81-b980-4645-9732-895bcfc5ae10" providerId="ADAL" clId="{5140C7B6-806A-5418-ABAC-628B6C6783E8}" dt="2026-10-28T02:34:15.892" v="12"/>
+          <ac:spMkLst>
+            <pc:docMk/>
+            <pc:sldMk cId="0" sldId="263"/>
+            <ac:spMk id="16" creationId="{82165CD9-EB48-03E4-3C48-661172A8BD0F}"/>
+          </ac:spMkLst>
+        </pc:spChg>
+        <pc:spChg chg="add">
+          <ac:chgData name="HARRIETT GUZMAN LOPEZ" userId="809bac81-b980-4645-9732-895bcfc5ae10" providerId="ADAL" clId="{5140C7B6-806A-5418-ABAC-628B6C6783E8}" dt="2026-10-28T02:34:19.622" v="14"/>
+          <ac:spMkLst>
+            <pc:docMk/>
+            <pc:sldMk cId="0" sldId="263"/>
+            <ac:spMk id="17" creationId="{C03949B8-E8A3-5756-8FC4-FF4E5A883FB5}"/>
+          </ac:spMkLst>
+        </pc:spChg>
+        <pc:spChg chg="add">
+          <ac:chgData name="HARRIETT GUZMAN LOPEZ" userId="809bac81-b980-4645-9732-895bcfc5ae10" providerId="ADAL" clId="{5140C7B6-806A-5418-ABAC-628B6C6783E8}" dt="2026-10-28T02:34:23.999" v="15"/>
+          <ac:spMkLst>
+            <pc:docMk/>
+            <pc:sldMk cId="0" sldId="263"/>
+            <ac:spMk id="18" creationId="{2D7E4F57-F8EC-7B21-7605-3EFB3B5A7419}"/>
+          </ac:spMkLst>
+        </pc:spChg>
+        <pc:spChg chg="add">
+          <ac:chgData name="HARRIETT GUZMAN LOPEZ" userId="809bac81-b980-4645-9732-895bcfc5ae10" providerId="ADAL" clId="{5140C7B6-806A-5418-ABAC-628B6C6783E8}" dt="2026-10-28T02:34:26.546" v="16"/>
+          <ac:spMkLst>
+            <pc:docMk/>
+            <pc:sldMk cId="0" sldId="263"/>
+            <ac:spMk id="19" creationId="{27FF6B6E-698E-C576-BA69-0F472D53CA90}"/>
+          </ac:spMkLst>
+        </pc:spChg>
+        <pc:spChg chg="add mod">
+          <ac:chgData name="HARRIETT GUZMAN LOPEZ" userId="809bac81-b980-4645-9732-895bcfc5ae10" providerId="ADAL" clId="{5140C7B6-806A-5418-ABAC-628B6C6783E8}" dt="2026-10-28T02:34:27.731" v="18"/>
+          <ac:spMkLst>
+            <pc:docMk/>
+            <pc:sldMk cId="0" sldId="263"/>
+            <ac:spMk id="20" creationId="{8F5C6C81-870E-80D2-98DB-BF9098211922}"/>
+          </ac:spMkLst>
+        </pc:spChg>
+        <pc:spChg chg="add">
+          <ac:chgData name="HARRIETT GUZMAN LOPEZ" userId="809bac81-b980-4645-9732-895bcfc5ae10" providerId="ADAL" clId="{5140C7B6-806A-5418-ABAC-628B6C6783E8}" dt="2026-10-28T02:34:34.211" v="21"/>
+          <ac:spMkLst>
+            <pc:docMk/>
+            <pc:sldMk cId="0" sldId="263"/>
+            <ac:spMk id="21" creationId="{CA1220A6-73FA-FA0F-C01F-345E205C1844}"/>
+          </ac:spMkLst>
+        </pc:spChg>
+      </pc:sldChg>
+      <pc:sldChg chg="addSp delSp modSp mod">
+        <pc:chgData name="HARRIETT GUZMAN LOPEZ" userId="809bac81-b980-4645-9732-895bcfc5ae10" providerId="ADAL" clId="{5140C7B6-806A-5418-ABAC-628B6C6783E8}" dt="2026-10-28T02:38:25.540" v="101"/>
+        <pc:sldMkLst>
+          <pc:docMk/>
+          <pc:sldMk cId="0" sldId="264"/>
+        </pc:sldMkLst>
+        <pc:spChg chg="mod">
+          <ac:chgData name="HARRIETT GUZMAN LOPEZ" userId="809bac81-b980-4645-9732-895bcfc5ae10" providerId="ADAL" clId="{5140C7B6-806A-5418-ABAC-628B6C6783E8}" dt="2026-10-28T02:38:25.540" v="101"/>
+          <ac:spMkLst>
+            <pc:docMk/>
+            <pc:sldMk cId="0" sldId="264"/>
+            <ac:spMk id="9" creationId="{00000000-0000-0000-0000-000000000000}"/>
+          </ac:spMkLst>
+        </pc:spChg>
+        <pc:picChg chg="del">
+          <ac:chgData name="HARRIETT GUZMAN LOPEZ" userId="809bac81-b980-4645-9732-895bcfc5ae10" providerId="ADAL" clId="{5140C7B6-806A-5418-ABAC-628B6C6783E8}" dt="2026-10-28T02:36:22.837" v="36" actId="478"/>
+          <ac:picMkLst>
+            <pc:docMk/>
+            <pc:sldMk cId="0" sldId="264"/>
+            <ac:picMk id="4" creationId="{00000000-0000-0000-0000-000000000000}"/>
+          </ac:picMkLst>
+        </pc:picChg>
+        <pc:picChg chg="add del mod">
+          <ac:chgData name="HARRIETT GUZMAN LOPEZ" userId="809bac81-b980-4645-9732-895bcfc5ae10" providerId="ADAL" clId="{5140C7B6-806A-5418-ABAC-628B6C6783E8}" dt="2026-10-28T02:36:46.182" v="41" actId="478"/>
+          <ac:picMkLst>
+            <pc:docMk/>
+            <pc:sldMk cId="0" sldId="264"/>
+            <ac:picMk id="11" creationId="{475779A3-45E8-DABE-DEED-FBB5475A2A9F}"/>
+          </ac:picMkLst>
+        </pc:picChg>
+        <pc:picChg chg="add del mod">
+          <ac:chgData name="HARRIETT GUZMAN LOPEZ" userId="809bac81-b980-4645-9732-895bcfc5ae10" providerId="ADAL" clId="{5140C7B6-806A-5418-ABAC-628B6C6783E8}" dt="2026-10-28T02:37:05.903" v="48" actId="478"/>
+          <ac:picMkLst>
+            <pc:docMk/>
+            <pc:sldMk cId="0" sldId="264"/>
+            <ac:picMk id="12" creationId="{7EC68088-144B-10A7-3D7C-DEF011B632C0}"/>
+          </ac:picMkLst>
+        </pc:picChg>
+        <pc:picChg chg="add mod">
+          <ac:chgData name="HARRIETT GUZMAN LOPEZ" userId="809bac81-b980-4645-9732-895bcfc5ae10" providerId="ADAL" clId="{5140C7B6-806A-5418-ABAC-628B6C6783E8}" dt="2026-10-28T02:37:26.151" v="53" actId="1076"/>
+          <ac:picMkLst>
+            <pc:docMk/>
+            <pc:sldMk cId="0" sldId="264"/>
+            <ac:picMk id="13" creationId="{640577B5-F17B-FD79-43D0-CC047046F116}"/>
+          </ac:picMkLst>
+        </pc:picChg>
+      </pc:sldChg>
+      <pc:sldChg chg="addSp delSp modSp mod">
+        <pc:chgData name="HARRIETT GUZMAN LOPEZ" userId="809bac81-b980-4645-9732-895bcfc5ae10" providerId="ADAL" clId="{5140C7B6-806A-5418-ABAC-628B6C6783E8}" dt="2026-10-28T02:41:19.011" v="257" actId="20577"/>
+        <pc:sldMkLst>
+          <pc:docMk/>
+          <pc:sldMk cId="0" sldId="266"/>
+        </pc:sldMkLst>
+        <pc:spChg chg="mod">
+          <ac:chgData name="HARRIETT GUZMAN LOPEZ" userId="809bac81-b980-4645-9732-895bcfc5ae10" providerId="ADAL" clId="{5140C7B6-806A-5418-ABAC-628B6C6783E8}" dt="2026-10-28T02:39:02.556" v="118" actId="20577"/>
+          <ac:spMkLst>
+            <pc:docMk/>
+            <pc:sldMk cId="0" sldId="266"/>
+            <ac:spMk id="4" creationId="{00000000-0000-0000-0000-000000000000}"/>
+          </ac:spMkLst>
+        </pc:spChg>
+        <pc:spChg chg="mod">
+          <ac:chgData name="HARRIETT GUZMAN LOPEZ" userId="809bac81-b980-4645-9732-895bcfc5ae10" providerId="ADAL" clId="{5140C7B6-806A-5418-ABAC-628B6C6783E8}" dt="2026-10-28T02:40:00.235" v="146" actId="20577"/>
+          <ac:spMkLst>
+            <pc:docMk/>
+            <pc:sldMk cId="0" sldId="266"/>
+            <ac:spMk id="5" creationId="{00000000-0000-0000-0000-000000000000}"/>
+          </ac:spMkLst>
+        </pc:spChg>
+        <pc:spChg chg="mod">
+          <ac:chgData name="HARRIETT GUZMAN LOPEZ" userId="809bac81-b980-4645-9732-895bcfc5ae10" providerId="ADAL" clId="{5140C7B6-806A-5418-ABAC-628B6C6783E8}" dt="2026-10-28T02:40:14.385" v="153" actId="20577"/>
+          <ac:spMkLst>
+            <pc:docMk/>
+            <pc:sldMk cId="0" sldId="266"/>
+            <ac:spMk id="7" creationId="{00000000-0000-0000-0000-000000000000}"/>
+          </ac:spMkLst>
+        </pc:spChg>
+        <pc:spChg chg="mod">
+          <ac:chgData name="HARRIETT GUZMAN LOPEZ" userId="809bac81-b980-4645-9732-895bcfc5ae10" providerId="ADAL" clId="{5140C7B6-806A-5418-ABAC-628B6C6783E8}" dt="2026-10-28T02:41:19.011" v="257" actId="20577"/>
+          <ac:spMkLst>
+            <pc:docMk/>
+            <pc:sldMk cId="0" sldId="266"/>
+            <ac:spMk id="8" creationId="{00000000-0000-0000-0000-000000000000}"/>
+          </ac:spMkLst>
+        </pc:spChg>
+        <pc:spChg chg="mod">
+          <ac:chgData name="HARRIETT GUZMAN LOPEZ" userId="809bac81-b980-4645-9732-895bcfc5ae10" providerId="ADAL" clId="{5140C7B6-806A-5418-ABAC-628B6C6783E8}" dt="2026-10-28T02:41:00.204" v="227" actId="20577"/>
+          <ac:spMkLst>
+            <pc:docMk/>
+            <pc:sldMk cId="0" sldId="266"/>
+            <ac:spMk id="10" creationId="{00000000-0000-0000-0000-000000000000}"/>
+          </ac:spMkLst>
+        </pc:spChg>
+        <pc:spChg chg="mod">
+          <ac:chgData name="HARRIETT GUZMAN LOPEZ" userId="809bac81-b980-4645-9732-895bcfc5ae10" providerId="ADAL" clId="{5140C7B6-806A-5418-ABAC-628B6C6783E8}" dt="2026-10-28T02:41:17.524" v="256" actId="20577"/>
+          <ac:spMkLst>
+            <pc:docMk/>
+            <pc:sldMk cId="0" sldId="266"/>
+            <ac:spMk id="11" creationId="{00000000-0000-0000-0000-000000000000}"/>
+          </ac:spMkLst>
+        </pc:spChg>
+        <pc:picChg chg="del">
+          <ac:chgData name="HARRIETT GUZMAN LOPEZ" userId="809bac81-b980-4645-9732-895bcfc5ae10" providerId="ADAL" clId="{5140C7B6-806A-5418-ABAC-628B6C6783E8}" dt="2026-10-28T02:39:04.273" v="119" actId="478"/>
+          <ac:picMkLst>
+            <pc:docMk/>
+            <pc:sldMk cId="0" sldId="266"/>
+            <ac:picMk id="13" creationId="{00000000-0000-0000-0000-000000000000}"/>
+          </ac:picMkLst>
+        </pc:picChg>
+        <pc:picChg chg="add mod">
+          <ac:chgData name="HARRIETT GUZMAN LOPEZ" userId="809bac81-b980-4645-9732-895bcfc5ae10" providerId="ADAL" clId="{5140C7B6-806A-5418-ABAC-628B6C6783E8}" dt="2026-10-28T02:39:19.883" v="124" actId="1076"/>
+          <ac:picMkLst>
+            <pc:docMk/>
+            <pc:sldMk cId="0" sldId="266"/>
+            <ac:picMk id="15" creationId="{BFDB7E06-8792-E7DB-0732-3D35ABCC2418}"/>
+          </ac:picMkLst>
+        </pc:picChg>
+      </pc:sldChg>
+      <pc:sldChg chg="addSp delSp modSp mod">
+        <pc:chgData name="HARRIETT GUZMAN LOPEZ" userId="809bac81-b980-4645-9732-895bcfc5ae10" providerId="ADAL" clId="{5140C7B6-806A-5418-ABAC-628B6C6783E8}" dt="2026-10-28T02:42:16.506" v="263" actId="1076"/>
+        <pc:sldMkLst>
+          <pc:docMk/>
+          <pc:sldMk cId="0" sldId="267"/>
+        </pc:sldMkLst>
+        <pc:picChg chg="del">
+          <ac:chgData name="HARRIETT GUZMAN LOPEZ" userId="809bac81-b980-4645-9732-895bcfc5ae10" providerId="ADAL" clId="{5140C7B6-806A-5418-ABAC-628B6C6783E8}" dt="2026-10-28T02:41:55.312" v="258" actId="478"/>
+          <ac:picMkLst>
+            <pc:docMk/>
+            <pc:sldMk cId="0" sldId="267"/>
+            <ac:picMk id="4" creationId="{00000000-0000-0000-0000-000000000000}"/>
+          </ac:picMkLst>
+        </pc:picChg>
+        <pc:picChg chg="add mod">
+          <ac:chgData name="HARRIETT GUZMAN LOPEZ" userId="809bac81-b980-4645-9732-895bcfc5ae10" providerId="ADAL" clId="{5140C7B6-806A-5418-ABAC-628B6C6783E8}" dt="2026-10-28T02:42:16.506" v="263" actId="1076"/>
+          <ac:picMkLst>
+            <pc:docMk/>
+            <pc:sldMk cId="0" sldId="267"/>
+            <ac:picMk id="12" creationId="{61E64541-E079-7026-6720-F007403B12AF}"/>
+          </ac:picMkLst>
+        </pc:picChg>
+      </pc:sldChg>
+      <pc:sldChg chg="addSp modSp mod">
+        <pc:chgData name="HARRIETT GUZMAN LOPEZ" userId="809bac81-b980-4645-9732-895bcfc5ae10" providerId="ADAL" clId="{5140C7B6-806A-5418-ABAC-628B6C6783E8}" dt="2026-10-28T02:43:04.135" v="271" actId="20577"/>
+        <pc:sldMkLst>
+          <pc:docMk/>
+          <pc:sldMk cId="0" sldId="268"/>
+        </pc:sldMkLst>
+        <pc:spChg chg="mod">
+          <ac:chgData name="HARRIETT GUZMAN LOPEZ" userId="809bac81-b980-4645-9732-895bcfc5ae10" providerId="ADAL" clId="{5140C7B6-806A-5418-ABAC-628B6C6783E8}" dt="2026-10-28T02:43:04.135" v="271" actId="20577"/>
+          <ac:spMkLst>
+            <pc:docMk/>
+            <pc:sldMk cId="0" sldId="268"/>
+            <ac:spMk id="9" creationId="{00000000-0000-0000-0000-000000000000}"/>
+          </ac:spMkLst>
+        </pc:spChg>
+        <pc:spChg chg="add">
+          <ac:chgData name="HARRIETT GUZMAN LOPEZ" userId="809bac81-b980-4645-9732-895bcfc5ae10" providerId="ADAL" clId="{5140C7B6-806A-5418-ABAC-628B6C6783E8}" dt="2026-10-28T02:42:48.294" v="264"/>
+          <ac:spMkLst>
+            <pc:docMk/>
+            <pc:sldMk cId="0" sldId="268"/>
+            <ac:spMk id="10" creationId="{78C72B8B-CC43-2BF1-836D-370CFC157F16}"/>
+          </ac:spMkLst>
+        </pc:spChg>
+        <pc:spChg chg="add">
+          <ac:chgData name="HARRIETT GUZMAN LOPEZ" userId="809bac81-b980-4645-9732-895bcfc5ae10" providerId="ADAL" clId="{5140C7B6-806A-5418-ABAC-628B6C6783E8}" dt="2026-10-28T02:42:51.778" v="267"/>
+          <ac:spMkLst>
+            <pc:docMk/>
+            <pc:sldMk cId="0" sldId="268"/>
+            <ac:spMk id="11" creationId="{220F6D0A-B8CB-7808-0AB3-8F6674B58C8E}"/>
+          </ac:spMkLst>
+        </pc:spChg>
+        <pc:spChg chg="add">
+          <ac:chgData name="HARRIETT GUZMAN LOPEZ" userId="809bac81-b980-4645-9732-895bcfc5ae10" providerId="ADAL" clId="{5140C7B6-806A-5418-ABAC-628B6C6783E8}" dt="2026-10-28T02:42:54.874" v="268"/>
+          <ac:spMkLst>
+            <pc:docMk/>
+            <pc:sldMk cId="0" sldId="268"/>
+            <ac:spMk id="12" creationId="{6F93CEFB-F4AE-3A0E-F050-1A9E3A6F9568}"/>
+          </ac:spMkLst>
+        </pc:spChg>
+        <pc:spChg chg="add">
+          <ac:chgData name="HARRIETT GUZMAN LOPEZ" userId="809bac81-b980-4645-9732-895bcfc5ae10" providerId="ADAL" clId="{5140C7B6-806A-5418-ABAC-628B6C6783E8}" dt="2026-10-28T02:43:00.587" v="269"/>
+          <ac:spMkLst>
+            <pc:docMk/>
+            <pc:sldMk cId="0" sldId="268"/>
+            <ac:spMk id="13" creationId="{C4AC54AC-AF50-E04D-09F3-9D59C52438A8}"/>
+          </ac:spMkLst>
+        </pc:spChg>
+      </pc:sldChg>
+    </pc:docChg>
+  </pc:docChgLst>
+</pc:chgInfo>
 </file>
 
 <file path=ppt/notesMasters/notesMaster1.xml><?xml version="1.0" encoding="utf-8"?>
@@ -2589,48 +2885,73 @@
                 <a:ea typeface="Calibri" pitchFamily="34" charset="-122"/>
                 <a:cs typeface="Calibri" pitchFamily="34" charset="-120"/>
               </a:rPr>
-              <a:t>66,140 usuarios con variables listas para análisis</a:t>
-            </a:r>
-            <a:endParaRPr lang="en-US" sz="1400" dirty="0">
-              <a:latin typeface="Century Schoolbook" panose="02040604050505020304" pitchFamily="18" charset="0"/>
-            </a:endParaRPr>
-          </a:p>
-        </p:txBody>
-      </p:sp>
-      <p:sp>
-        <p:nvSpPr>
-          <p:cNvPr id="15" name="Text 13"/>
-          <p:cNvSpPr txBox="1"/>
-          <p:nvPr/>
-        </p:nvSpPr>
-        <p:spPr>
-          <a:xfrm>
-            <a:off x="457200" y="4480560"/>
-            <a:ext cx="8229600" cy="320040"/>
-          </a:xfrm>
-          <a:prstGeom prst="rect">
-            <a:avLst/>
-          </a:prstGeom>
-          <a:noFill/>
-          <a:ln/>
-        </p:spPr>
-        <p:txBody>
-          <a:bodyPr wrap="square" lIns="0" tIns="0" rIns="0" bIns="0" rtlCol="0" anchor="ctr"/>
-          <a:lstStyle/>
-          <a:p>
-            <a:pPr marL="0" indent="0">
-              <a:buNone/>
-            </a:pPr>
-            <a:r>
-              <a:rPr lang="en-US" sz="1400" b="1" dirty="0">
-                <a:solidFill>
-                  <a:srgbClr val="CDE7F8"/>
+              <a:t>70,380 </a:t>
+            </a:r>
+            <a:r>
+              <a:rPr lang="en-US" sz="1400" dirty="0" err="1">
+                <a:solidFill>
+                  <a:srgbClr val="8EC5F0"/>
                 </a:solidFill>
                 <a:latin typeface="Century Schoolbook" panose="02040604050505020304" pitchFamily="18" charset="0"/>
                 <a:ea typeface="Calibri" pitchFamily="34" charset="-122"/>
                 <a:cs typeface="Calibri" pitchFamily="34" charset="-120"/>
               </a:rPr>
-              <a:t>29 modelos dbt construidos · 82 pruebas PASS</a:t>
+              <a:t>usuarios</a:t>
+            </a:r>
+            <a:r>
+              <a:rPr lang="en-US" sz="1400" dirty="0">
+                <a:solidFill>
+                  <a:srgbClr val="8EC5F0"/>
+                </a:solidFill>
+                <a:latin typeface="Century Schoolbook" panose="02040604050505020304" pitchFamily="18" charset="0"/>
+                <a:ea typeface="Calibri" pitchFamily="34" charset="-122"/>
+                <a:cs typeface="Calibri" pitchFamily="34" charset="-120"/>
+              </a:rPr>
+              <a:t> con variables </a:t>
+            </a:r>
+            <a:r>
+              <a:rPr lang="en-US" sz="1400" dirty="0" err="1">
+                <a:solidFill>
+                  <a:srgbClr val="8EC5F0"/>
+                </a:solidFill>
+                <a:latin typeface="Century Schoolbook" panose="02040604050505020304" pitchFamily="18" charset="0"/>
+                <a:ea typeface="Calibri" pitchFamily="34" charset="-122"/>
+                <a:cs typeface="Calibri" pitchFamily="34" charset="-120"/>
+              </a:rPr>
+              <a:t>listas</a:t>
+            </a:r>
+            <a:r>
+              <a:rPr lang="en-US" sz="1400" dirty="0">
+                <a:solidFill>
+                  <a:srgbClr val="8EC5F0"/>
+                </a:solidFill>
+                <a:latin typeface="Century Schoolbook" panose="02040604050505020304" pitchFamily="18" charset="0"/>
+                <a:ea typeface="Calibri" pitchFamily="34" charset="-122"/>
+                <a:cs typeface="Calibri" pitchFamily="34" charset="-120"/>
+              </a:rPr>
+              <a:t> para </a:t>
+            </a:r>
+            <a:r>
+              <a:rPr lang="en-US" sz="1400" dirty="0" err="1">
+                <a:solidFill>
+                  <a:srgbClr val="8EC5F0"/>
+                </a:solidFill>
+                <a:latin typeface="Century Schoolbook" panose="02040604050505020304" pitchFamily="18" charset="0"/>
+                <a:ea typeface="Calibri" pitchFamily="34" charset="-122"/>
+                <a:cs typeface="Calibri" pitchFamily="34" charset="-120"/>
+              </a:rPr>
+              <a:t>análisis</a:t>
+            </a:r>
+            <a:r>
+              <a:rPr lang="en-US" sz="1400" dirty="0">
+                <a:solidFill>
+                  <a:srgbClr val="8EC5F0"/>
+                </a:solidFill>
+                <a:latin typeface="Century Schoolbook" panose="02040604050505020304" pitchFamily="18" charset="0"/>
+                <a:ea typeface="Calibri" pitchFamily="34" charset="-122"/>
+                <a:cs typeface="Calibri" pitchFamily="34" charset="-120"/>
+              </a:rPr>
+              <a:t> </a:t>
             </a:r>
             <a:endParaRPr lang="en-US" sz="1400" dirty="0">
               <a:latin typeface="Century Schoolbook" panose="02040604050505020304" pitchFamily="18" charset="0"/>
@@ -4216,30 +4537,6 @@
           </a:p>
         </p:txBody>
       </p:sp>
-      <p:pic>
-        <p:nvPicPr>
-          <p:cNvPr id="4" name="Image 0" descr="/home/claude/img/a17.jpg"/>
-          <p:cNvPicPr>
-            <a:picLocks noChangeAspect="1"/>
-          </p:cNvPicPr>
-          <p:nvPr/>
-        </p:nvPicPr>
-        <p:blipFill>
-          <a:blip r:embed="rId3"/>
-          <a:stretch>
-            <a:fillRect/>
-          </a:stretch>
-        </p:blipFill>
-        <p:spPr>
-          <a:xfrm>
-            <a:off x="457200" y="1188720"/>
-            <a:ext cx="3931920" cy="2466624"/>
-          </a:xfrm>
-          <a:prstGeom prst="rect">
-            <a:avLst/>
-          </a:prstGeom>
-        </p:spPr>
-      </p:pic>
       <p:sp>
         <p:nvSpPr>
           <p:cNvPr id="5" name="Text 2"/>
@@ -4331,6 +4628,233 @@
           <p:nvPr/>
         </p:nvPicPr>
         <p:blipFill>
+          <a:blip r:embed="rId3"/>
+          <a:stretch>
+            <a:fillRect/>
+          </a:stretch>
+        </p:blipFill>
+        <p:spPr>
+          <a:xfrm>
+            <a:off x="4754880" y="1188720"/>
+            <a:ext cx="3931920" cy="2338182"/>
+          </a:xfrm>
+          <a:prstGeom prst="rect">
+            <a:avLst/>
+          </a:prstGeom>
+        </p:spPr>
+      </p:pic>
+      <p:sp>
+        <p:nvSpPr>
+          <p:cNvPr id="8" name="Text 4"/>
+          <p:cNvSpPr txBox="1"/>
+          <p:nvPr/>
+        </p:nvSpPr>
+        <p:spPr>
+          <a:xfrm>
+            <a:off x="4754880" y="3703320"/>
+            <a:ext cx="3931920" cy="274320"/>
+          </a:xfrm>
+          <a:prstGeom prst="rect">
+            <a:avLst/>
+          </a:prstGeom>
+          <a:noFill/>
+          <a:ln/>
+        </p:spPr>
+        <p:txBody>
+          <a:bodyPr wrap="square" lIns="0" tIns="0" rIns="0" bIns="0" rtlCol="0" anchor="ctr"/>
+          <a:lstStyle/>
+          <a:p>
+            <a:pPr marL="0" indent="0">
+              <a:buNone/>
+            </a:pPr>
+            <a:r>
+              <a:rPr lang="en-US" sz="1100" i="1" dirty="0">
+                <a:solidFill>
+                  <a:srgbClr val="5B7A99"/>
+                </a:solidFill>
+                <a:latin typeface="Century Schoolbook" panose="02040604050505020304" pitchFamily="18" charset="0"/>
+                <a:ea typeface="Calibri" pitchFamily="34" charset="-122"/>
+                <a:cs typeface="Calibri" pitchFamily="34" charset="-120"/>
+              </a:rPr>
+              <a:t>Anexo 19 · Abordajes por hora</a:t>
+            </a:r>
+            <a:endParaRPr lang="en-US" sz="1100" dirty="0">
+              <a:latin typeface="Century Schoolbook" panose="02040604050505020304" pitchFamily="18" charset="0"/>
+            </a:endParaRPr>
+          </a:p>
+        </p:txBody>
+      </p:sp>
+      <p:sp>
+        <p:nvSpPr>
+          <p:cNvPr id="9" name="Text 5"/>
+          <p:cNvSpPr txBox="1"/>
+          <p:nvPr/>
+        </p:nvSpPr>
+        <p:spPr>
+          <a:xfrm>
+            <a:off x="457200" y="4023360"/>
+            <a:ext cx="3931920" cy="640080"/>
+          </a:xfrm>
+          <a:prstGeom prst="rect">
+            <a:avLst/>
+          </a:prstGeom>
+          <a:noFill/>
+          <a:ln/>
+        </p:spPr>
+        <p:txBody>
+          <a:bodyPr wrap="square" lIns="0" tIns="0" rIns="0" bIns="0" rtlCol="0" anchor="ctr"/>
+          <a:lstStyle/>
+          <a:p>
+            <a:r>
+              <a:rPr lang="en-US" sz="1300" b="1" dirty="0" err="1">
+                <a:solidFill>
+                  <a:srgbClr val="12304F"/>
+                </a:solidFill>
+                <a:latin typeface="Century Schoolbook" panose="02040604050505020304" pitchFamily="18" charset="0"/>
+                <a:ea typeface="Calibri" pitchFamily="34" charset="-122"/>
+                <a:cs typeface="Calibri" pitchFamily="34" charset="-120"/>
+              </a:rPr>
+              <a:t>Transurbano</a:t>
+            </a:r>
+            <a:r>
+              <a:rPr lang="en-US" sz="1300" b="1" dirty="0">
+                <a:solidFill>
+                  <a:srgbClr val="12304F"/>
+                </a:solidFill>
+                <a:latin typeface="Century Schoolbook" panose="02040604050505020304" pitchFamily="18" charset="0"/>
+                <a:ea typeface="Calibri" pitchFamily="34" charset="-122"/>
+                <a:cs typeface="Calibri" pitchFamily="34" charset="-120"/>
+              </a:rPr>
+              <a:t>: 786,398 · </a:t>
+            </a:r>
+            <a:r>
+              <a:rPr lang="en-US" sz="1300" b="1" dirty="0" err="1">
+                <a:solidFill>
+                  <a:srgbClr val="12304F"/>
+                </a:solidFill>
+                <a:latin typeface="Century Schoolbook" panose="02040604050505020304" pitchFamily="18" charset="0"/>
+                <a:ea typeface="Calibri" pitchFamily="34" charset="-122"/>
+                <a:cs typeface="Calibri" pitchFamily="34" charset="-120"/>
+              </a:rPr>
+              <a:t>Metroriel</a:t>
+            </a:r>
+            <a:r>
+              <a:rPr lang="en-US" sz="1300" b="1" dirty="0">
+                <a:solidFill>
+                  <a:srgbClr val="12304F"/>
+                </a:solidFill>
+                <a:latin typeface="Century Schoolbook" panose="02040604050505020304" pitchFamily="18" charset="0"/>
+                <a:ea typeface="Calibri" pitchFamily="34" charset="-122"/>
+                <a:cs typeface="Calibri" pitchFamily="34" charset="-120"/>
+              </a:rPr>
+              <a:t> 295,111 </a:t>
+            </a:r>
+            <a:r>
+              <a:rPr lang="en-US" sz="1300" b="1" dirty="0" err="1">
+                <a:solidFill>
+                  <a:srgbClr val="12304F"/>
+                </a:solidFill>
+                <a:latin typeface="Century Schoolbook" panose="02040604050505020304" pitchFamily="18" charset="0"/>
+                <a:ea typeface="Calibri" pitchFamily="34" charset="-122"/>
+                <a:cs typeface="Calibri" pitchFamily="34" charset="-120"/>
+              </a:rPr>
+              <a:t>Transmetro</a:t>
+            </a:r>
+            <a:r>
+              <a:rPr lang="en-US" sz="1300" b="1" dirty="0">
+                <a:solidFill>
+                  <a:srgbClr val="12304F"/>
+                </a:solidFill>
+                <a:latin typeface="Century Schoolbook" panose="02040604050505020304" pitchFamily="18" charset="0"/>
+                <a:ea typeface="Calibri" pitchFamily="34" charset="-122"/>
+                <a:cs typeface="Calibri" pitchFamily="34" charset="-120"/>
+              </a:rPr>
+              <a:t> 362,106 · </a:t>
+            </a:r>
+            <a:r>
+              <a:rPr lang="en-US" sz="1300" b="1" dirty="0" err="1">
+                <a:solidFill>
+                  <a:srgbClr val="12304F"/>
+                </a:solidFill>
+                <a:latin typeface="Century Schoolbook" panose="02040604050505020304" pitchFamily="18" charset="0"/>
+                <a:ea typeface="Calibri" pitchFamily="34" charset="-122"/>
+                <a:cs typeface="Calibri" pitchFamily="34" charset="-120"/>
+              </a:rPr>
+              <a:t>Aerometro</a:t>
+            </a:r>
+            <a:r>
+              <a:rPr lang="en-US" sz="1300" b="1" dirty="0">
+                <a:solidFill>
+                  <a:srgbClr val="12304F"/>
+                </a:solidFill>
+                <a:latin typeface="Century Schoolbook" panose="02040604050505020304" pitchFamily="18" charset="0"/>
+                <a:ea typeface="Calibri" pitchFamily="34" charset="-122"/>
+                <a:cs typeface="Calibri" pitchFamily="34" charset="-120"/>
+              </a:rPr>
+              <a:t> 203,554</a:t>
+            </a:r>
+            <a:endParaRPr lang="en-US" sz="1300" dirty="0">
+              <a:latin typeface="Century Schoolbook" panose="02040604050505020304" pitchFamily="18" charset="0"/>
+            </a:endParaRPr>
+          </a:p>
+        </p:txBody>
+      </p:sp>
+      <p:sp>
+        <p:nvSpPr>
+          <p:cNvPr id="10" name="Text 6"/>
+          <p:cNvSpPr txBox="1"/>
+          <p:nvPr/>
+        </p:nvSpPr>
+        <p:spPr>
+          <a:xfrm>
+            <a:off x="4754880" y="4023360"/>
+            <a:ext cx="3931920" cy="640080"/>
+          </a:xfrm>
+          <a:prstGeom prst="rect">
+            <a:avLst/>
+          </a:prstGeom>
+          <a:noFill/>
+          <a:ln/>
+        </p:spPr>
+        <p:txBody>
+          <a:bodyPr wrap="square" lIns="0" tIns="0" rIns="0" bIns="0" rtlCol="0" anchor="ctr"/>
+          <a:lstStyle/>
+          <a:p>
+            <a:pPr marL="0" indent="0">
+              <a:buNone/>
+            </a:pPr>
+            <a:r>
+              <a:rPr lang="en-US" sz="1300" b="1" dirty="0">
+                <a:solidFill>
+                  <a:srgbClr val="12304F"/>
+                </a:solidFill>
+                <a:latin typeface="Century Schoolbook" panose="02040604050505020304" pitchFamily="18" charset="0"/>
+                <a:ea typeface="Calibri" pitchFamily="34" charset="-122"/>
+                <a:cs typeface="Calibri" pitchFamily="34" charset="-120"/>
+              </a:rPr>
+              <a:t>Dos picos: 7:00 con 162,014 y 17:00 con 137,152 abordajes</a:t>
+            </a:r>
+            <a:endParaRPr lang="en-US" sz="1300" dirty="0">
+              <a:latin typeface="Century Schoolbook" panose="02040604050505020304" pitchFamily="18" charset="0"/>
+            </a:endParaRPr>
+          </a:p>
+        </p:txBody>
+      </p:sp>
+      <p:pic>
+        <p:nvPicPr>
+          <p:cNvPr id="13" name="Imagen 12">
+            <a:extLst>
+              <a:ext uri="{FF2B5EF4-FFF2-40B4-BE49-F238E27FC236}">
+                <a16:creationId xmlns:a16="http://schemas.microsoft.com/office/drawing/2014/main" id="{640577B5-F17B-FD79-43D0-CC047046F116}"/>
+              </a:ext>
+            </a:extLst>
+          </p:cNvPr>
+          <p:cNvPicPr>
+            <a:picLocks noChangeAspect="1"/>
+          </p:cNvPicPr>
+          <p:nvPr/>
+        </p:nvPicPr>
+        <p:blipFill>
           <a:blip r:embed="rId4"/>
           <a:stretch>
             <a:fillRect/>
@@ -4338,137 +4862,14 @@
         </p:blipFill>
         <p:spPr>
           <a:xfrm>
-            <a:off x="4754880" y="1188720"/>
-            <a:ext cx="3931920" cy="2338182"/>
+            <a:off x="402336" y="1189577"/>
+            <a:ext cx="4038374" cy="2392189"/>
           </a:xfrm>
           <a:prstGeom prst="rect">
             <a:avLst/>
           </a:prstGeom>
         </p:spPr>
       </p:pic>
-      <p:sp>
-        <p:nvSpPr>
-          <p:cNvPr id="8" name="Text 4"/>
-          <p:cNvSpPr txBox="1"/>
-          <p:nvPr/>
-        </p:nvSpPr>
-        <p:spPr>
-          <a:xfrm>
-            <a:off x="4754880" y="3703320"/>
-            <a:ext cx="3931920" cy="274320"/>
-          </a:xfrm>
-          <a:prstGeom prst="rect">
-            <a:avLst/>
-          </a:prstGeom>
-          <a:noFill/>
-          <a:ln/>
-        </p:spPr>
-        <p:txBody>
-          <a:bodyPr wrap="square" lIns="0" tIns="0" rIns="0" bIns="0" rtlCol="0" anchor="ctr"/>
-          <a:lstStyle/>
-          <a:p>
-            <a:pPr marL="0" indent="0">
-              <a:buNone/>
-            </a:pPr>
-            <a:r>
-              <a:rPr lang="en-US" sz="1100" i="1" dirty="0">
-                <a:solidFill>
-                  <a:srgbClr val="5B7A99"/>
-                </a:solidFill>
-                <a:latin typeface="Century Schoolbook" panose="02040604050505020304" pitchFamily="18" charset="0"/>
-                <a:ea typeface="Calibri" pitchFamily="34" charset="-122"/>
-                <a:cs typeface="Calibri" pitchFamily="34" charset="-120"/>
-              </a:rPr>
-              <a:t>Anexo 19 · Abordajes por hora</a:t>
-            </a:r>
-            <a:endParaRPr lang="en-US" sz="1100" dirty="0">
-              <a:latin typeface="Century Schoolbook" panose="02040604050505020304" pitchFamily="18" charset="0"/>
-            </a:endParaRPr>
-          </a:p>
-        </p:txBody>
-      </p:sp>
-      <p:sp>
-        <p:nvSpPr>
-          <p:cNvPr id="9" name="Text 5"/>
-          <p:cNvSpPr txBox="1"/>
-          <p:nvPr/>
-        </p:nvSpPr>
-        <p:spPr>
-          <a:xfrm>
-            <a:off x="457200" y="4023360"/>
-            <a:ext cx="3931920" cy="640080"/>
-          </a:xfrm>
-          <a:prstGeom prst="rect">
-            <a:avLst/>
-          </a:prstGeom>
-          <a:noFill/>
-          <a:ln/>
-        </p:spPr>
-        <p:txBody>
-          <a:bodyPr wrap="square" lIns="0" tIns="0" rIns="0" bIns="0" rtlCol="0" anchor="ctr"/>
-          <a:lstStyle/>
-          <a:p>
-            <a:pPr marL="0" indent="0">
-              <a:buNone/>
-            </a:pPr>
-            <a:r>
-              <a:rPr lang="en-US" sz="1300" b="1" dirty="0">
-                <a:solidFill>
-                  <a:srgbClr val="12304F"/>
-                </a:solidFill>
-                <a:latin typeface="Century Schoolbook" panose="02040604050505020304" pitchFamily="18" charset="0"/>
-                <a:ea typeface="Calibri" pitchFamily="34" charset="-122"/>
-                <a:cs typeface="Calibri" pitchFamily="34" charset="-120"/>
-              </a:rPr>
-              <a:t>Transurbano lidera: 786,398 abordajes (Transmetro 362,106 · Aerometro 203,554)</a:t>
-            </a:r>
-            <a:endParaRPr lang="en-US" sz="1300" dirty="0">
-              <a:latin typeface="Century Schoolbook" panose="02040604050505020304" pitchFamily="18" charset="0"/>
-            </a:endParaRPr>
-          </a:p>
-        </p:txBody>
-      </p:sp>
-      <p:sp>
-        <p:nvSpPr>
-          <p:cNvPr id="10" name="Text 6"/>
-          <p:cNvSpPr txBox="1"/>
-          <p:nvPr/>
-        </p:nvSpPr>
-        <p:spPr>
-          <a:xfrm>
-            <a:off x="4754880" y="4023360"/>
-            <a:ext cx="3931920" cy="640080"/>
-          </a:xfrm>
-          <a:prstGeom prst="rect">
-            <a:avLst/>
-          </a:prstGeom>
-          <a:noFill/>
-          <a:ln/>
-        </p:spPr>
-        <p:txBody>
-          <a:bodyPr wrap="square" lIns="0" tIns="0" rIns="0" bIns="0" rtlCol="0" anchor="ctr"/>
-          <a:lstStyle/>
-          <a:p>
-            <a:pPr marL="0" indent="0">
-              <a:buNone/>
-            </a:pPr>
-            <a:r>
-              <a:rPr lang="en-US" sz="1300" b="1" dirty="0">
-                <a:solidFill>
-                  <a:srgbClr val="12304F"/>
-                </a:solidFill>
-                <a:latin typeface="Century Schoolbook" panose="02040604050505020304" pitchFamily="18" charset="0"/>
-                <a:ea typeface="Calibri" pitchFamily="34" charset="-122"/>
-                <a:cs typeface="Calibri" pitchFamily="34" charset="-120"/>
-              </a:rPr>
-              <a:t>Dos picos: 7:00 con 162,014 y 17:00 con 137,152 abordajes</a:t>
-            </a:r>
-            <a:endParaRPr lang="en-US" sz="1300" dirty="0">
-              <a:latin typeface="Century Schoolbook" panose="02040604050505020304" pitchFamily="18" charset="0"/>
-            </a:endParaRPr>
-          </a:p>
-        </p:txBody>
-      </p:sp>
     </p:spTree>
   </p:cSld>
   <p:clrMapOvr>
@@ -5141,10 +5542,8 @@
                   <a:srgbClr val="FFFFFF"/>
                 </a:solidFill>
                 <a:latin typeface="Century Schoolbook" panose="02040604050505020304" pitchFamily="18" charset="0"/>
-                <a:ea typeface="Cambria" pitchFamily="34" charset="-122"/>
-                <a:cs typeface="Cambria" pitchFamily="34" charset="-120"/>
-              </a:rPr>
-              <a:t>36,829</a:t>
+              </a:rPr>
+              <a:t>70, 380</a:t>
             </a:r>
             <a:endParaRPr lang="en-US" sz="2400" dirty="0">
               <a:latin typeface="Century Schoolbook" panose="02040604050505020304" pitchFamily="18" charset="0"/>
@@ -5177,7 +5576,7 @@
               <a:buNone/>
             </a:pPr>
             <a:r>
-              <a:rPr lang="en-US" sz="1200" dirty="0">
+              <a:rPr lang="en-US" sz="1200" dirty="0" err="1">
                 <a:solidFill>
                   <a:srgbClr val="DCEBFA"/>
                 </a:solidFill>
@@ -5185,7 +5584,29 @@
                 <a:ea typeface="Calibri" pitchFamily="34" charset="-122"/>
                 <a:cs typeface="Calibri" pitchFamily="34" charset="-120"/>
               </a:rPr>
-              <a:t>usuarios con 2 o más modos</a:t>
+              <a:t>usuarios</a:t>
+            </a:r>
+            <a:r>
+              <a:rPr lang="en-US" sz="1200" dirty="0">
+                <a:solidFill>
+                  <a:srgbClr val="DCEBFA"/>
+                </a:solidFill>
+                <a:latin typeface="Century Schoolbook" panose="02040604050505020304" pitchFamily="18" charset="0"/>
+                <a:ea typeface="Calibri" pitchFamily="34" charset="-122"/>
+                <a:cs typeface="Calibri" pitchFamily="34" charset="-120"/>
+              </a:rPr>
+              <a:t> </a:t>
+            </a:r>
+            <a:r>
+              <a:rPr lang="en-US" sz="1200" dirty="0" err="1">
+                <a:solidFill>
+                  <a:srgbClr val="DCEBFA"/>
+                </a:solidFill>
+                <a:latin typeface="Century Schoolbook" panose="02040604050505020304" pitchFamily="18" charset="0"/>
+                <a:ea typeface="Calibri" pitchFamily="34" charset="-122"/>
+                <a:cs typeface="Calibri" pitchFamily="34" charset="-120"/>
+              </a:rPr>
+              <a:t>analizados</a:t>
             </a:r>
             <a:endParaRPr lang="en-US" sz="1200" dirty="0">
               <a:latin typeface="Century Schoolbook" panose="02040604050505020304" pitchFamily="18" charset="0"/>
@@ -5262,7 +5683,7 @@
                 <a:ea typeface="Cambria" pitchFamily="34" charset="-122"/>
                 <a:cs typeface="Cambria" pitchFamily="34" charset="-120"/>
               </a:rPr>
-              <a:t>33,551 · 26,833 · 9,996</a:t>
+              <a:t>14, 496</a:t>
             </a:r>
             <a:endParaRPr lang="en-US" sz="2000" dirty="0">
               <a:latin typeface="Century Schoolbook" panose="02040604050505020304" pitchFamily="18" charset="0"/>
@@ -5295,15 +5716,54 @@
               <a:buNone/>
             </a:pPr>
             <a:r>
+              <a:rPr lang="en-US" sz="1200" dirty="0" err="1">
+                <a:solidFill>
+                  <a:srgbClr val="12304F"/>
+                </a:solidFill>
+                <a:latin typeface="Century Schoolbook" panose="02040604050505020304" pitchFamily="18" charset="0"/>
+                <a:cs typeface="Calibri" pitchFamily="34" charset="-120"/>
+              </a:rPr>
+              <a:t>usuarios</a:t>
+            </a:r>
+            <a:r>
               <a:rPr lang="en-US" sz="1200" dirty="0">
                 <a:solidFill>
                   <a:srgbClr val="12304F"/>
                 </a:solidFill>
                 <a:latin typeface="Century Schoolbook" panose="02040604050505020304" pitchFamily="18" charset="0"/>
-                <a:ea typeface="Calibri" pitchFamily="34" charset="-122"/>
                 <a:cs typeface="Calibri" pitchFamily="34" charset="-120"/>
               </a:rPr>
-              <a:t>usuarios con 1, 2 y 3 modos</a:t>
+              <a:t> </a:t>
+            </a:r>
+            <a:r>
+              <a:rPr lang="en-US" sz="1200" dirty="0" err="1">
+                <a:solidFill>
+                  <a:srgbClr val="12304F"/>
+                </a:solidFill>
+                <a:latin typeface="Century Schoolbook" panose="02040604050505020304" pitchFamily="18" charset="0"/>
+                <a:cs typeface="Calibri" pitchFamily="34" charset="-120"/>
+              </a:rPr>
+              <a:t>excluxivos</a:t>
+            </a:r>
+            <a:r>
+              <a:rPr lang="en-US" sz="1200" dirty="0">
+                <a:solidFill>
+                  <a:srgbClr val="12304F"/>
+                </a:solidFill>
+                <a:latin typeface="Century Schoolbook" panose="02040604050505020304" pitchFamily="18" charset="0"/>
+                <a:cs typeface="Calibri" pitchFamily="34" charset="-120"/>
+              </a:rPr>
+              <a:t> de </a:t>
+            </a:r>
+            <a:r>
+              <a:rPr lang="en-US" sz="1200" dirty="0" err="1">
+                <a:solidFill>
+                  <a:srgbClr val="12304F"/>
+                </a:solidFill>
+                <a:latin typeface="Century Schoolbook" panose="02040604050505020304" pitchFamily="18" charset="0"/>
+                <a:cs typeface="Calibri" pitchFamily="34" charset="-120"/>
+              </a:rPr>
+              <a:t>Aerómetro</a:t>
             </a:r>
             <a:endParaRPr lang="en-US" sz="1200" dirty="0">
               <a:latin typeface="Century Schoolbook" panose="02040604050505020304" pitchFamily="18" charset="0"/>
@@ -5380,7 +5840,7 @@
                 <a:ea typeface="Cambria" pitchFamily="34" charset="-122"/>
                 <a:cs typeface="Cambria" pitchFamily="34" charset="-120"/>
               </a:rPr>
-              <a:t>66,140</a:t>
+              <a:t>55, 884</a:t>
             </a:r>
             <a:endParaRPr lang="en-US" sz="2400" dirty="0">
               <a:latin typeface="Century Schoolbook" panose="02040604050505020304" pitchFamily="18" charset="0"/>
@@ -5413,7 +5873,7 @@
               <a:buNone/>
             </a:pPr>
             <a:r>
-              <a:rPr lang="en-US" sz="1200" dirty="0">
+              <a:rPr lang="en-US" sz="1200" dirty="0" err="1">
                 <a:solidFill>
                   <a:srgbClr val="12304F"/>
                 </a:solidFill>
@@ -5421,7 +5881,51 @@
                 <a:ea typeface="Calibri" pitchFamily="34" charset="-122"/>
                 <a:cs typeface="Calibri" pitchFamily="34" charset="-120"/>
               </a:rPr>
-              <a:t>usuarios en features_usuario_movilidad</a:t>
+              <a:t>usuarios</a:t>
+            </a:r>
+            <a:r>
+              <a:rPr lang="en-US" sz="1200" dirty="0">
+                <a:solidFill>
+                  <a:srgbClr val="12304F"/>
+                </a:solidFill>
+                <a:latin typeface="Century Schoolbook" panose="02040604050505020304" pitchFamily="18" charset="0"/>
+                <a:ea typeface="Calibri" pitchFamily="34" charset="-122"/>
+                <a:cs typeface="Calibri" pitchFamily="34" charset="-120"/>
+              </a:rPr>
+              <a:t> al </a:t>
+            </a:r>
+            <a:r>
+              <a:rPr lang="en-US" sz="1200" dirty="0" err="1">
+                <a:solidFill>
+                  <a:srgbClr val="12304F"/>
+                </a:solidFill>
+                <a:latin typeface="Century Schoolbook" panose="02040604050505020304" pitchFamily="18" charset="0"/>
+                <a:ea typeface="Calibri" pitchFamily="34" charset="-122"/>
+                <a:cs typeface="Calibri" pitchFamily="34" charset="-120"/>
+              </a:rPr>
+              <a:t>excluir</a:t>
+            </a:r>
+            <a:r>
+              <a:rPr lang="en-US" sz="1200" dirty="0">
+                <a:solidFill>
+                  <a:srgbClr val="12304F"/>
+                </a:solidFill>
+                <a:latin typeface="Century Schoolbook" panose="02040604050505020304" pitchFamily="18" charset="0"/>
+                <a:ea typeface="Calibri" pitchFamily="34" charset="-122"/>
+                <a:cs typeface="Calibri" pitchFamily="34" charset="-120"/>
+              </a:rPr>
+              <a:t> </a:t>
+            </a:r>
+            <a:r>
+              <a:rPr lang="en-US" sz="1200" dirty="0" err="1">
+                <a:solidFill>
+                  <a:srgbClr val="12304F"/>
+                </a:solidFill>
+                <a:latin typeface="Century Schoolbook" panose="02040604050505020304" pitchFamily="18" charset="0"/>
+                <a:ea typeface="Calibri" pitchFamily="34" charset="-122"/>
+                <a:cs typeface="Calibri" pitchFamily="34" charset="-120"/>
+              </a:rPr>
+              <a:t>Aerómetro</a:t>
             </a:r>
             <a:endParaRPr lang="en-US" sz="1200" dirty="0">
               <a:latin typeface="Century Schoolbook" panose="02040604050505020304" pitchFamily="18" charset="0"/>
@@ -5468,9 +5972,56 @@
           </a:p>
         </p:txBody>
       </p:sp>
+      <p:sp>
+        <p:nvSpPr>
+          <p:cNvPr id="14" name="Text 11"/>
+          <p:cNvSpPr txBox="1"/>
+          <p:nvPr/>
+        </p:nvSpPr>
+        <p:spPr>
+          <a:xfrm>
+            <a:off x="4206240" y="4160520"/>
+            <a:ext cx="4480560" cy="274320"/>
+          </a:xfrm>
+          <a:prstGeom prst="rect">
+            <a:avLst/>
+          </a:prstGeom>
+          <a:noFill/>
+          <a:ln/>
+        </p:spPr>
+        <p:txBody>
+          <a:bodyPr wrap="square" lIns="0" tIns="0" rIns="0" bIns="0" rtlCol="0" anchor="ctr"/>
+          <a:lstStyle/>
+          <a:p>
+            <a:pPr marL="0" indent="0">
+              <a:buNone/>
+            </a:pPr>
+            <a:r>
+              <a:rPr lang="en-US" sz="1100" i="1" dirty="0">
+                <a:solidFill>
+                  <a:srgbClr val="5B7A99"/>
+                </a:solidFill>
+                <a:latin typeface="Century Schoolbook" panose="02040604050505020304" pitchFamily="18" charset="0"/>
+                <a:ea typeface="Calibri" pitchFamily="34" charset="-122"/>
+                <a:cs typeface="Calibri" pitchFamily="34" charset="-120"/>
+              </a:rPr>
+              <a:t>Anexo 20 · Usuarios según cantidad de modos</a:t>
+            </a:r>
+            <a:endParaRPr lang="en-US" sz="1100" dirty="0">
+              <a:latin typeface="Century Schoolbook" panose="02040604050505020304" pitchFamily="18" charset="0"/>
+            </a:endParaRPr>
+          </a:p>
+        </p:txBody>
+      </p:sp>
       <p:pic>
         <p:nvPicPr>
-          <p:cNvPr id="13" name="Image 0" descr="/home/claude/img/a20.jpg"/>
+          <p:cNvPr id="15" name="Imagen 14">
+            <a:extLst>
+              <a:ext uri="{FF2B5EF4-FFF2-40B4-BE49-F238E27FC236}">
+                <a16:creationId xmlns:a16="http://schemas.microsoft.com/office/drawing/2014/main" id="{BFDB7E06-8792-E7DB-0732-3D35ABCC2418}"/>
+              </a:ext>
+            </a:extLst>
+          </p:cNvPr>
           <p:cNvPicPr>
             <a:picLocks noChangeAspect="1"/>
           </p:cNvPicPr>
@@ -5484,55 +6035,14 @@
         </p:blipFill>
         <p:spPr>
           <a:xfrm>
-            <a:off x="4206240" y="1280160"/>
-            <a:ext cx="4480560" cy="2810805"/>
+            <a:off x="4151376" y="1307580"/>
+            <a:ext cx="4692717" cy="2779799"/>
           </a:xfrm>
           <a:prstGeom prst="rect">
             <a:avLst/>
           </a:prstGeom>
         </p:spPr>
       </p:pic>
-      <p:sp>
-        <p:nvSpPr>
-          <p:cNvPr id="14" name="Text 11"/>
-          <p:cNvSpPr txBox="1"/>
-          <p:nvPr/>
-        </p:nvSpPr>
-        <p:spPr>
-          <a:xfrm>
-            <a:off x="4206240" y="4160520"/>
-            <a:ext cx="4480560" cy="274320"/>
-          </a:xfrm>
-          <a:prstGeom prst="rect">
-            <a:avLst/>
-          </a:prstGeom>
-          <a:noFill/>
-          <a:ln/>
-        </p:spPr>
-        <p:txBody>
-          <a:bodyPr wrap="square" lIns="0" tIns="0" rIns="0" bIns="0" rtlCol="0" anchor="ctr"/>
-          <a:lstStyle/>
-          <a:p>
-            <a:pPr marL="0" indent="0">
-              <a:buNone/>
-            </a:pPr>
-            <a:r>
-              <a:rPr lang="en-US" sz="1100" i="1" dirty="0">
-                <a:solidFill>
-                  <a:srgbClr val="5B7A99"/>
-                </a:solidFill>
-                <a:latin typeface="Century Schoolbook" panose="02040604050505020304" pitchFamily="18" charset="0"/>
-                <a:ea typeface="Calibri" pitchFamily="34" charset="-122"/>
-                <a:cs typeface="Calibri" pitchFamily="34" charset="-120"/>
-              </a:rPr>
-              <a:t>Anexo 20 · Usuarios según cantidad de modos</a:t>
-            </a:r>
-            <a:endParaRPr lang="en-US" sz="1100" dirty="0">
-              <a:latin typeface="Century Schoolbook" panose="02040604050505020304" pitchFamily="18" charset="0"/>
-            </a:endParaRPr>
-          </a:p>
-        </p:txBody>
-      </p:sp>
     </p:spTree>
   </p:cSld>
   <p:clrMapOvr>
@@ -5644,30 +6154,6 @@
           </a:p>
         </p:txBody>
       </p:sp>
-      <p:pic>
-        <p:nvPicPr>
-          <p:cNvPr id="4" name="Image 0" descr="/home/claude/img/a23.jpg"/>
-          <p:cNvPicPr>
-            <a:picLocks noChangeAspect="1"/>
-          </p:cNvPicPr>
-          <p:nvPr/>
-        </p:nvPicPr>
-        <p:blipFill>
-          <a:blip r:embed="rId3"/>
-          <a:stretch>
-            <a:fillRect/>
-          </a:stretch>
-        </p:blipFill>
-        <p:spPr>
-          <a:xfrm>
-            <a:off x="457200" y="1188720"/>
-            <a:ext cx="5577840" cy="3316956"/>
-          </a:xfrm>
-          <a:prstGeom prst="rect">
-            <a:avLst/>
-          </a:prstGeom>
-        </p:spPr>
-      </p:pic>
       <p:sp>
         <p:nvSpPr>
           <p:cNvPr id="5" name="Text 2"/>
@@ -5928,6 +6414,36 @@
           </a:p>
         </p:txBody>
       </p:sp>
+      <p:pic>
+        <p:nvPicPr>
+          <p:cNvPr id="12" name="Imagen 11">
+            <a:extLst>
+              <a:ext uri="{FF2B5EF4-FFF2-40B4-BE49-F238E27FC236}">
+                <a16:creationId xmlns:a16="http://schemas.microsoft.com/office/drawing/2014/main" id="{61E64541-E079-7026-6720-F007403B12AF}"/>
+              </a:ext>
+            </a:extLst>
+          </p:cNvPr>
+          <p:cNvPicPr>
+            <a:picLocks noChangeAspect="1"/>
+          </p:cNvPicPr>
+          <p:nvPr/>
+        </p:nvPicPr>
+        <p:blipFill>
+          <a:blip r:embed="rId3"/>
+          <a:stretch>
+            <a:fillRect/>
+          </a:stretch>
+        </p:blipFill>
+        <p:spPr>
+          <a:xfrm>
+            <a:off x="355050" y="1163996"/>
+            <a:ext cx="5782139" cy="3425134"/>
+          </a:xfrm>
+          <a:prstGeom prst="rect">
+            <a:avLst/>
+          </a:prstGeom>
+        </p:spPr>
+      </p:pic>
     </p:spTree>
   </p:cSld>
   <p:clrMapOvr>
@@ -6327,7 +6843,7 @@
               <a:buNone/>
             </a:pPr>
             <a:r>
-              <a:rPr lang="en-US" sz="1300" b="1" dirty="0">
+              <a:rPr lang="en-US" sz="1300" b="1" dirty="0" err="1">
                 <a:solidFill>
                   <a:srgbClr val="FFFFFF"/>
                 </a:solidFill>
@@ -6335,18 +6851,238 @@
                 <a:ea typeface="Calibri" pitchFamily="34" charset="-122"/>
                 <a:cs typeface="Calibri" pitchFamily="34" charset="-120"/>
               </a:rPr>
-              <a:t>Propuesta: </a:t>
-            </a:r>
-            <a:r>
-              <a:rPr lang="en-US" sz="1300" dirty="0">
-                <a:solidFill>
-                  <a:srgbClr val="DCEBFA"/>
+              <a:t>Propuesta</a:t>
+            </a:r>
+            <a:r>
+              <a:rPr lang="en-US" sz="1300" b="1" dirty="0">
+                <a:solidFill>
+                  <a:srgbClr val="FFFFFF"/>
                 </a:solidFill>
                 <a:latin typeface="Century Schoolbook" panose="02040604050505020304" pitchFamily="18" charset="0"/>
                 <a:ea typeface="Calibri" pitchFamily="34" charset="-122"/>
                 <a:cs typeface="Calibri" pitchFamily="34" charset="-120"/>
               </a:rPr>
-              <a:t>MetroRiel no registra abordajes en estas zonas. Priorizar su cobertura y reforzar capacidad a las 7:00 y 17:00.</a:t>
+              <a:t>: </a:t>
+            </a:r>
+            <a:r>
+              <a:rPr lang="en-US" sz="1300" dirty="0" err="1">
+                <a:solidFill>
+                  <a:srgbClr val="DCEBFA"/>
+                </a:solidFill>
+                <a:latin typeface="Century Schoolbook" panose="02040604050505020304" pitchFamily="18" charset="0"/>
+                <a:ea typeface="Calibri" pitchFamily="34" charset="-122"/>
+                <a:cs typeface="Calibri" pitchFamily="34" charset="-120"/>
+              </a:rPr>
+              <a:t>MetroRiel</a:t>
+            </a:r>
+            <a:r>
+              <a:rPr lang="en-US" sz="1300" dirty="0">
+                <a:solidFill>
+                  <a:srgbClr val="DCEBFA"/>
+                </a:solidFill>
+                <a:latin typeface="Century Schoolbook" panose="02040604050505020304" pitchFamily="18" charset="0"/>
+                <a:ea typeface="Calibri" pitchFamily="34" charset="-122"/>
+                <a:cs typeface="Calibri" pitchFamily="34" charset="-120"/>
+              </a:rPr>
+              <a:t> no </a:t>
+            </a:r>
+            <a:r>
+              <a:rPr lang="en-US" sz="1300" dirty="0" err="1">
+                <a:solidFill>
+                  <a:srgbClr val="DCEBFA"/>
+                </a:solidFill>
+                <a:latin typeface="Century Schoolbook" panose="02040604050505020304" pitchFamily="18" charset="0"/>
+                <a:ea typeface="Calibri" pitchFamily="34" charset="-122"/>
+                <a:cs typeface="Calibri" pitchFamily="34" charset="-120"/>
+              </a:rPr>
+              <a:t>registra</a:t>
+            </a:r>
+            <a:r>
+              <a:rPr lang="en-US" sz="1300" dirty="0">
+                <a:solidFill>
+                  <a:srgbClr val="DCEBFA"/>
+                </a:solidFill>
+                <a:latin typeface="Century Schoolbook" panose="02040604050505020304" pitchFamily="18" charset="0"/>
+                <a:ea typeface="Calibri" pitchFamily="34" charset="-122"/>
+                <a:cs typeface="Calibri" pitchFamily="34" charset="-120"/>
+              </a:rPr>
+              <a:t> </a:t>
+            </a:r>
+            <a:r>
+              <a:rPr lang="en-US" sz="1300" dirty="0" err="1">
+                <a:solidFill>
+                  <a:srgbClr val="DCEBFA"/>
+                </a:solidFill>
+                <a:latin typeface="Century Schoolbook" panose="02040604050505020304" pitchFamily="18" charset="0"/>
+                <a:ea typeface="Calibri" pitchFamily="34" charset="-122"/>
+                <a:cs typeface="Calibri" pitchFamily="34" charset="-120"/>
+              </a:rPr>
+              <a:t>abordajes</a:t>
+            </a:r>
+            <a:r>
+              <a:rPr lang="en-US" sz="1300" dirty="0">
+                <a:solidFill>
+                  <a:srgbClr val="DCEBFA"/>
+                </a:solidFill>
+                <a:latin typeface="Century Schoolbook" panose="02040604050505020304" pitchFamily="18" charset="0"/>
+                <a:ea typeface="Calibri" pitchFamily="34" charset="-122"/>
+                <a:cs typeface="Calibri" pitchFamily="34" charset="-120"/>
+              </a:rPr>
+              <a:t> </a:t>
+            </a:r>
+            <a:r>
+              <a:rPr lang="en-US" sz="1300" dirty="0" err="1">
+                <a:solidFill>
+                  <a:srgbClr val="DCEBFA"/>
+                </a:solidFill>
+                <a:latin typeface="Century Schoolbook" panose="02040604050505020304" pitchFamily="18" charset="0"/>
+                <a:ea typeface="Calibri" pitchFamily="34" charset="-122"/>
+                <a:cs typeface="Calibri" pitchFamily="34" charset="-120"/>
+              </a:rPr>
+              <a:t>en</a:t>
+            </a:r>
+            <a:r>
+              <a:rPr lang="en-US" sz="1300" dirty="0">
+                <a:solidFill>
+                  <a:srgbClr val="DCEBFA"/>
+                </a:solidFill>
+                <a:latin typeface="Century Schoolbook" panose="02040604050505020304" pitchFamily="18" charset="0"/>
+                <a:ea typeface="Calibri" pitchFamily="34" charset="-122"/>
+                <a:cs typeface="Calibri" pitchFamily="34" charset="-120"/>
+              </a:rPr>
+              <a:t> </a:t>
+            </a:r>
+            <a:r>
+              <a:rPr lang="en-US" sz="1300" dirty="0" err="1">
+                <a:solidFill>
+                  <a:srgbClr val="DCEBFA"/>
+                </a:solidFill>
+                <a:latin typeface="Century Schoolbook" panose="02040604050505020304" pitchFamily="18" charset="0"/>
+                <a:ea typeface="Calibri" pitchFamily="34" charset="-122"/>
+                <a:cs typeface="Calibri" pitchFamily="34" charset="-120"/>
+              </a:rPr>
+              <a:t>estas</a:t>
+            </a:r>
+            <a:r>
+              <a:rPr lang="en-US" sz="1300" dirty="0">
+                <a:solidFill>
+                  <a:srgbClr val="DCEBFA"/>
+                </a:solidFill>
+                <a:latin typeface="Century Schoolbook" panose="02040604050505020304" pitchFamily="18" charset="0"/>
+                <a:ea typeface="Calibri" pitchFamily="34" charset="-122"/>
+                <a:cs typeface="Calibri" pitchFamily="34" charset="-120"/>
+              </a:rPr>
+              <a:t> zonas. </a:t>
+            </a:r>
+            <a:r>
+              <a:rPr lang="en-US" sz="1300" dirty="0" err="1">
+                <a:solidFill>
+                  <a:srgbClr val="DCEBFA"/>
+                </a:solidFill>
+                <a:latin typeface="Century Schoolbook" panose="02040604050505020304" pitchFamily="18" charset="0"/>
+                <a:ea typeface="Calibri" pitchFamily="34" charset="-122"/>
+                <a:cs typeface="Calibri" pitchFamily="34" charset="-120"/>
+              </a:rPr>
+              <a:t>Priorizar</a:t>
+            </a:r>
+            <a:r>
+              <a:rPr lang="en-US" sz="1300" dirty="0">
+                <a:solidFill>
+                  <a:srgbClr val="DCEBFA"/>
+                </a:solidFill>
+                <a:latin typeface="Century Schoolbook" panose="02040604050505020304" pitchFamily="18" charset="0"/>
+                <a:ea typeface="Calibri" pitchFamily="34" charset="-122"/>
+                <a:cs typeface="Calibri" pitchFamily="34" charset="-120"/>
+              </a:rPr>
+              <a:t> </a:t>
+            </a:r>
+            <a:r>
+              <a:rPr lang="en-US" sz="1300" dirty="0" err="1">
+                <a:solidFill>
+                  <a:srgbClr val="DCEBFA"/>
+                </a:solidFill>
+                <a:latin typeface="Century Schoolbook" panose="02040604050505020304" pitchFamily="18" charset="0"/>
+                <a:ea typeface="Calibri" pitchFamily="34" charset="-122"/>
+                <a:cs typeface="Calibri" pitchFamily="34" charset="-120"/>
+              </a:rPr>
+              <a:t>su</a:t>
+            </a:r>
+            <a:r>
+              <a:rPr lang="en-US" sz="1300" dirty="0">
+                <a:solidFill>
+                  <a:srgbClr val="DCEBFA"/>
+                </a:solidFill>
+                <a:latin typeface="Century Schoolbook" panose="02040604050505020304" pitchFamily="18" charset="0"/>
+                <a:ea typeface="Calibri" pitchFamily="34" charset="-122"/>
+                <a:cs typeface="Calibri" pitchFamily="34" charset="-120"/>
+              </a:rPr>
+              <a:t> </a:t>
+            </a:r>
+            <a:r>
+              <a:rPr lang="en-US" sz="1300" dirty="0" err="1">
+                <a:solidFill>
+                  <a:srgbClr val="DCEBFA"/>
+                </a:solidFill>
+                <a:latin typeface="Century Schoolbook" panose="02040604050505020304" pitchFamily="18" charset="0"/>
+                <a:ea typeface="Calibri" pitchFamily="34" charset="-122"/>
+                <a:cs typeface="Calibri" pitchFamily="34" charset="-120"/>
+              </a:rPr>
+              <a:t>cobertura</a:t>
+            </a:r>
+            <a:r>
+              <a:rPr lang="en-US" sz="1300" dirty="0">
+                <a:solidFill>
+                  <a:srgbClr val="DCEBFA"/>
+                </a:solidFill>
+                <a:latin typeface="Century Schoolbook" panose="02040604050505020304" pitchFamily="18" charset="0"/>
+                <a:ea typeface="Calibri" pitchFamily="34" charset="-122"/>
+                <a:cs typeface="Calibri" pitchFamily="34" charset="-120"/>
+              </a:rPr>
+              <a:t> y </a:t>
+            </a:r>
+            <a:r>
+              <a:rPr lang="en-US" sz="1300" dirty="0" err="1">
+                <a:solidFill>
+                  <a:srgbClr val="DCEBFA"/>
+                </a:solidFill>
+                <a:latin typeface="Century Schoolbook" panose="02040604050505020304" pitchFamily="18" charset="0"/>
+                <a:ea typeface="Calibri" pitchFamily="34" charset="-122"/>
+                <a:cs typeface="Calibri" pitchFamily="34" charset="-120"/>
+              </a:rPr>
+              <a:t>reforzar</a:t>
+            </a:r>
+            <a:r>
+              <a:rPr lang="en-US" sz="1300" dirty="0">
+                <a:solidFill>
+                  <a:srgbClr val="DCEBFA"/>
+                </a:solidFill>
+                <a:latin typeface="Century Schoolbook" panose="02040604050505020304" pitchFamily="18" charset="0"/>
+                <a:ea typeface="Calibri" pitchFamily="34" charset="-122"/>
+                <a:cs typeface="Calibri" pitchFamily="34" charset="-120"/>
+              </a:rPr>
+              <a:t> </a:t>
+            </a:r>
+            <a:r>
+              <a:rPr lang="en-US" sz="1300" dirty="0" err="1">
+                <a:solidFill>
+                  <a:srgbClr val="DCEBFA"/>
+                </a:solidFill>
+                <a:latin typeface="Century Schoolbook" panose="02040604050505020304" pitchFamily="18" charset="0"/>
+                <a:ea typeface="Calibri" pitchFamily="34" charset="-122"/>
+                <a:cs typeface="Calibri" pitchFamily="34" charset="-120"/>
+              </a:rPr>
+              <a:t>capacidad</a:t>
+            </a:r>
+            <a:r>
+              <a:rPr lang="en-US" sz="1300" dirty="0">
+                <a:solidFill>
+                  <a:srgbClr val="DCEBFA"/>
+                </a:solidFill>
+                <a:latin typeface="Century Schoolbook" panose="02040604050505020304" pitchFamily="18" charset="0"/>
+                <a:ea typeface="Calibri" pitchFamily="34" charset="-122"/>
+                <a:cs typeface="Calibri" pitchFamily="34" charset="-120"/>
+              </a:rPr>
+              <a:t> a las 7:00 y 17:00.</a:t>
             </a:r>
             <a:endParaRPr lang="en-US" sz="1300" dirty="0">
               <a:latin typeface="Century Schoolbook" panose="02040604050505020304" pitchFamily="18" charset="0"/>
@@ -13030,7 +13766,7 @@
                 <a:ea typeface="Cambria" pitchFamily="34" charset="-122"/>
                 <a:cs typeface="Cambria" pitchFamily="34" charset="-120"/>
               </a:rPr>
-              <a:t>31,050</a:t>
+              <a:t>15,611</a:t>
             </a:r>
             <a:endParaRPr lang="en-US" sz="2400" dirty="0">
               <a:latin typeface="Century Schoolbook" panose="02040604050505020304" pitchFamily="18" charset="0"/>
@@ -13266,7 +14002,7 @@
                 <a:ea typeface="Cambria" pitchFamily="34" charset="-122"/>
                 <a:cs typeface="Cambria" pitchFamily="34" charset="-120"/>
               </a:rPr>
-              <a:t>18,431</a:t>
+              <a:t>515</a:t>
             </a:r>
             <a:endParaRPr lang="en-US" sz="2400" dirty="0">
               <a:latin typeface="Century Schoolbook" panose="02040604050505020304" pitchFamily="18" charset="0"/>

</xml_diff>